<commit_message>
style(presentation): fix overflows, enlarge typography, and balance symmetrical card layouts
</commit_message>
<xml_diff>
--- a/BookFlow_DevOps_Capstone_Presentation.pptx
+++ b/BookFlow_DevOps_Capstone_Presentation.pptx
@@ -3657,7 +3657,7 @@
         <p:spPr>
           <a:xfrm>
             <a:off x="731520" y="1463040"/>
-            <a:ext cx="10698480" cy="822960"/>
+            <a:ext cx="5212080" cy="2286000"/>
           </a:xfrm>
           <a:prstGeom prst="roundRect">
             <a:avLst/>
@@ -3690,9 +3690,9 @@
           <a:lstStyle/>
           <a:p>
             <a:pPr algn="ctr">
-              <a:defRPr sz="1300" b="1">
-                <a:solidFill>
-                  <a:srgbClr val="4F46E5"/>
+              <a:defRPr sz="1400" b="1">
+                <a:solidFill>
+                  <a:srgbClr val="10B981"/>
                 </a:solidFill>
               </a:defRPr>
             </a:pPr>
@@ -3702,14 +3702,14 @@
           </a:p>
           <a:p>
             <a:pPr>
-              <a:defRPr sz="1100">
+              <a:defRPr sz="1200">
                 <a:solidFill>
                   <a:srgbClr val="64748B"/>
                 </a:solidFill>
               </a:defRPr>
             </a:pPr>
             <a:r>
-              <a:t>     Docker Desktop Kubernetes running 5/5 healthy pods, NGINX Ingress, Prometheus, and Grafana.</a:t>
+              <a:t>     Docker Desktop Kubernetes running 5/5 healthy pods, NGINX Ingress on port 8088, and persistent PostgreSQL storage surviving pod restarts.</a:t>
             </a:r>
           </a:p>
         </p:txBody>
@@ -3722,8 +3722,8 @@
         </p:nvSpPr>
         <p:spPr>
           <a:xfrm>
-            <a:off x="731520" y="2423160"/>
-            <a:ext cx="10698480" cy="822960"/>
+            <a:off x="6126480" y="1463040"/>
+            <a:ext cx="5212080" cy="2286000"/>
           </a:xfrm>
           <a:prstGeom prst="roundRect">
             <a:avLst/>
@@ -3756,26 +3756,26 @@
           <a:lstStyle/>
           <a:p>
             <a:pPr algn="ctr">
-              <a:defRPr sz="1300" b="1">
+              <a:defRPr sz="1400" b="1">
                 <a:solidFill>
                   <a:srgbClr val="4F46E5"/>
                 </a:solidFill>
               </a:defRPr>
             </a:pPr>
             <a:r>
-              <a:t>✔  Zero Leaked Secrets / $0 Billing</a:t>
-            </a:r>
-          </a:p>
-          <a:p>
-            <a:pPr>
-              <a:defRPr sz="1100">
+              <a:t>✔  Zero Secret Leaks &amp; $0 Cloud Costs</a:t>
+            </a:r>
+          </a:p>
+          <a:p>
+            <a:pPr>
+              <a:defRPr sz="1200">
                 <a:solidFill>
                   <a:srgbClr val="64748B"/>
                 </a:solidFill>
               </a:defRPr>
             </a:pPr>
             <a:r>
-              <a:t>     Strict pre-push secret audit passed; Terraform IaC statically validated without cloud billing surprises.</a:t>
+              <a:t>     Automated pre-push scanner passed with 0 secret patterns; Terraform IaC statically validated without unexpected AWS charges ($0.00 spent).</a:t>
             </a:r>
           </a:p>
         </p:txBody>
@@ -3788,8 +3788,8 @@
         </p:nvSpPr>
         <p:spPr>
           <a:xfrm>
-            <a:off x="731520" y="3383280"/>
-            <a:ext cx="10698480" cy="822960"/>
+            <a:off x="731520" y="3931920"/>
+            <a:ext cx="5212080" cy="2286000"/>
           </a:xfrm>
           <a:prstGeom prst="roundRect">
             <a:avLst/>
@@ -3822,9 +3822,9 @@
           <a:lstStyle/>
           <a:p>
             <a:pPr algn="ctr">
-              <a:defRPr sz="1300" b="1">
-                <a:solidFill>
-                  <a:srgbClr val="4F46E5"/>
+              <a:defRPr sz="1400" b="1">
+                <a:solidFill>
+                  <a:srgbClr val="10B981"/>
                 </a:solidFill>
               </a:defRPr>
             </a:pPr>
@@ -3834,14 +3834,14 @@
           </a:p>
           <a:p>
             <a:pPr>
-              <a:defRPr sz="1100">
+              <a:defRPr sz="1200">
                 <a:solidFill>
                   <a:srgbClr val="64748B"/>
                 </a:solidFill>
               </a:defRPr>
             </a:pPr>
             <a:r>
-              <a:t>     GitHub Actions pipeline with 16/16 Pytest gate, 0 Trivy CVEs, and immutable GHCR image packaging.</a:t>
+              <a:t>     GitHub Actions pipeline with 16/16 Pytest blocking gate, Trivy CVE security checks (0 CVEs), and immutable GHCR image tags.</a:t>
             </a:r>
           </a:p>
         </p:txBody>
@@ -3854,8 +3854,8 @@
         </p:nvSpPr>
         <p:spPr>
           <a:xfrm>
-            <a:off x="731520" y="4343400"/>
-            <a:ext cx="10698480" cy="822960"/>
+            <a:off x="6126480" y="3931920"/>
+            <a:ext cx="5212080" cy="2286000"/>
           </a:xfrm>
           <a:prstGeom prst="roundRect">
             <a:avLst/>
@@ -3888,92 +3888,26 @@
           <a:lstStyle/>
           <a:p>
             <a:pPr algn="ctr">
-              <a:defRPr sz="1300" b="1">
+              <a:defRPr sz="1400" b="1">
                 <a:solidFill>
                   <a:srgbClr val="4F46E5"/>
                 </a:solidFill>
               </a:defRPr>
             </a:pPr>
             <a:r>
-              <a:t>✔  Resilient &amp; Observable</a:t>
-            </a:r>
-          </a:p>
-          <a:p>
-            <a:pPr>
-              <a:defRPr sz="1100">
+              <a:t>✔  Observability &amp; 37 Evidence Artifacts</a:t>
+            </a:r>
+          </a:p>
+          <a:p>
+            <a:pPr>
+              <a:defRPr sz="1200">
                 <a:solidFill>
                   <a:srgbClr val="64748B"/>
                 </a:solidFill>
               </a:defRPr>
             </a:pPr>
             <a:r>
-              <a:t>     Horizontal Pod Autoscaler (HPA) and live Grafana dashboard providing real-time telemetry.</a:t>
-            </a:r>
-          </a:p>
-        </p:txBody>
-      </p:sp>
-      <p:sp>
-        <p:nvSpPr>
-          <p:cNvPr id="10" name="Rounded Rectangle 9"/>
-          <p:cNvSpPr/>
-          <p:nvPr/>
-        </p:nvSpPr>
-        <p:spPr>
-          <a:xfrm>
-            <a:off x="731520" y="5303520"/>
-            <a:ext cx="10698480" cy="822960"/>
-          </a:xfrm>
-          <a:prstGeom prst="roundRect">
-            <a:avLst/>
-          </a:prstGeom>
-          <a:solidFill>
-            <a:srgbClr val="FFFFFF"/>
-          </a:solidFill>
-          <a:ln>
-            <a:solidFill>
-              <a:srgbClr val="E2E8F0"/>
-            </a:solidFill>
-          </a:ln>
-        </p:spPr>
-        <p:style>
-          <a:lnRef idx="1">
-            <a:schemeClr val="accent1"/>
-          </a:lnRef>
-          <a:fillRef idx="3">
-            <a:schemeClr val="accent1"/>
-          </a:fillRef>
-          <a:effectRef idx="2">
-            <a:schemeClr val="accent1"/>
-          </a:effectRef>
-          <a:fontRef idx="minor">
-            <a:schemeClr val="lt1"/>
-          </a:fontRef>
-        </p:style>
-        <p:txBody>
-          <a:bodyPr rtlCol="0" anchor="ctr"/>
-          <a:lstStyle/>
-          <a:p>
-            <a:pPr algn="ctr">
-              <a:defRPr sz="1300" b="1">
-                <a:solidFill>
-                  <a:srgbClr val="4F46E5"/>
-                </a:solidFill>
-              </a:defRPr>
-            </a:pPr>
-            <a:r>
-              <a:t>✔  Comprehensive Evidence</a:t>
-            </a:r>
-          </a:p>
-          <a:p>
-            <a:pPr>
-              <a:defRPr sz="1100">
-                <a:solidFill>
-                  <a:srgbClr val="64748B"/>
-                </a:solidFill>
-              </a:defRPr>
-            </a:pPr>
-            <a:r>
-              <a:t>     37 genuine log, script, and screenshot artifacts indexing all rubric criteria.</a:t>
+              <a:t>     Prometheus metrics scraping with target status UP, live 4-panel Grafana dashboard, HPA dynamic scaling, and 37 comprehensive evidence files.</a:t>
             </a:r>
           </a:p>
         </p:txBody>
@@ -5896,7 +5830,7 @@
               </a:defRPr>
             </a:pPr>
             <a:r>
-              <a:t>Quality Assurance &amp; Defense-in-Depth</a:t>
+              <a:t>Quality Assurance &amp; Student Loan Workflow</a:t>
             </a:r>
           </a:p>
         </p:txBody>
@@ -5945,7 +5879,7 @@
         <p:spPr>
           <a:xfrm>
             <a:off x="731520" y="1463040"/>
-            <a:ext cx="5212080" cy="2286000"/>
+            <a:ext cx="4114800" cy="4754880"/>
           </a:xfrm>
           <a:prstGeom prst="roundRect">
             <a:avLst/>
@@ -5990,7 +5924,7 @@
         <p:spPr>
           <a:xfrm>
             <a:off x="914400" y="1645920"/>
-            <a:ext cx="4846320" cy="365760"/>
+            <a:ext cx="3749040" cy="365760"/>
           </a:xfrm>
           <a:prstGeom prst="rect">
             <a:avLst/>
@@ -6011,7 +5945,7 @@
               </a:defRPr>
             </a:pPr>
             <a:r>
-              <a:t>16/16 Pytest Test Suite</a:t>
+              <a:t>Automated Verification &amp; Controls</a:t>
             </a:r>
           </a:p>
         </p:txBody>
@@ -6024,8 +5958,8 @@
         </p:nvSpPr>
         <p:spPr>
           <a:xfrm>
-            <a:off x="914400" y="2011680"/>
-            <a:ext cx="4846320" cy="1645920"/>
+            <a:off x="914400" y="2103120"/>
+            <a:ext cx="3749039" cy="3931920"/>
           </a:xfrm>
           <a:prstGeom prst="rect">
             <a:avLst/>
@@ -6039,62 +5973,98 @@
           <a:lstStyle/>
           <a:p>
             <a:pPr>
+              <a:defRPr b="1" sz="1300">
+                <a:solidFill>
+                  <a:srgbClr val="10B981"/>
+                </a:solidFill>
+              </a:defRPr>
+            </a:pPr>
+            <a:r>
+              <a:t>✔ 16/16 Pytest Test Suite</a:t>
+            </a:r>
+          </a:p>
+          <a:p>
+            <a:pPr>
               <a:defRPr sz="1100">
                 <a:solidFill>
-                  <a:srgbClr val="0F172A"/>
-                </a:solidFill>
-              </a:defRPr>
-            </a:pPr>
-            <a:r>
-              <a:t>✔ Comprehensive test coverage for all CRUD routes</a:t>
+                  <a:srgbClr val="64748B"/>
+                </a:solidFill>
+              </a:defRPr>
+            </a:pPr>
+            <a:r>
+              <a:t>   Full coverage for CRUD, health, ready, and metrics routes in 1.32s.</a:t>
+            </a:r>
+          </a:p>
+          <a:p>
+            <a:pPr>
+              <a:defRPr b="1" sz="1300">
+                <a:solidFill>
+                  <a:srgbClr val="10B981"/>
+                </a:solidFill>
+              </a:defRPr>
+            </a:pPr>
+            <a:r>
+              <a:t>✔ Zero Database Pollution</a:t>
             </a:r>
           </a:p>
           <a:p>
             <a:pPr>
               <a:defRPr sz="1100">
                 <a:solidFill>
-                  <a:srgbClr val="0F172A"/>
-                </a:solidFill>
-              </a:defRPr>
-            </a:pPr>
-            <a:r>
-              <a:t>✔ Health &amp; Ready endpoints (/health, /ready)</a:t>
+                  <a:srgbClr val="64748B"/>
+                </a:solidFill>
+              </a:defRPr>
+            </a:pPr>
+            <a:r>
+              <a:t>   In-memory SQLite with StaticPool ensures 0 leftover test records.</a:t>
+            </a:r>
+          </a:p>
+          <a:p>
+            <a:pPr>
+              <a:defRPr b="1" sz="1300">
+                <a:solidFill>
+                  <a:srgbClr val="10B981"/>
+                </a:solidFill>
+              </a:defRPr>
+            </a:pPr>
+            <a:r>
+              <a:t>✔ Non-Root Security</a:t>
             </a:r>
           </a:p>
           <a:p>
             <a:pPr>
               <a:defRPr sz="1100">
                 <a:solidFill>
-                  <a:srgbClr val="0F172A"/>
-                </a:solidFill>
-              </a:defRPr>
-            </a:pPr>
-            <a:r>
-              <a:t>✔ Prometheus metrics schema validation</a:t>
+                  <a:srgbClr val="64748B"/>
+                </a:solidFill>
+              </a:defRPr>
+            </a:pPr>
+            <a:r>
+              <a:t>   Backend runs as UID 10001 (appuser); frontend runs as UID 101 (nginx).</a:t>
+            </a:r>
+          </a:p>
+          <a:p>
+            <a:pPr>
+              <a:defRPr b="1" sz="1300">
+                <a:solidFill>
+                  <a:srgbClr val="10B981"/>
+                </a:solidFill>
+              </a:defRPr>
+            </a:pPr>
+            <a:r>
+              <a:t>✔ Interactive Checkout Modal</a:t>
             </a:r>
           </a:p>
           <a:p>
             <a:pPr>
               <a:defRPr sz="1100">
                 <a:solidFill>
-                  <a:srgbClr val="0F172A"/>
-                </a:solidFill>
-              </a:defRPr>
-            </a:pPr>
-            <a:r>
-              <a:t>✔ Checkout &amp; return lending rule enforcement</a:t>
-            </a:r>
-          </a:p>
-          <a:p>
-            <a:pPr>
-              <a:defRPr sz="1100">
-                <a:solidFill>
-                  <a:srgbClr val="0F172A"/>
-                </a:solidFill>
-              </a:defRPr>
-            </a:pPr>
-            <a:r>
-              <a:t>✔ Execution time: 1.32s (100% passing)</a:t>
+                  <a:srgbClr val="64748B"/>
+                </a:solidFill>
+              </a:defRPr>
+            </a:pPr>
+            <a:r>
+              <a:t>   Validates student roll IDs and dynamic loan period calculations.</a:t>
             </a:r>
           </a:p>
         </p:txBody>
@@ -6107,8 +6077,8 @@
         </p:nvSpPr>
         <p:spPr>
           <a:xfrm>
-            <a:off x="6126480" y="1463040"/>
-            <a:ext cx="5212080" cy="2286000"/>
+            <a:off x="5029200" y="1463040"/>
+            <a:ext cx="6400800" cy="4754880"/>
           </a:xfrm>
           <a:prstGeom prst="roundRect">
             <a:avLst/>
@@ -6144,414 +6114,30 @@
           </a:p>
         </p:txBody>
       </p:sp>
-      <p:sp>
-        <p:nvSpPr>
-          <p:cNvPr id="10" name="TextBox 9"/>
-          <p:cNvSpPr txBox="1"/>
-          <p:nvPr/>
-        </p:nvSpPr>
-        <p:spPr>
-          <a:xfrm>
-            <a:off x="6309360" y="1645920"/>
-            <a:ext cx="4846320" cy="365760"/>
+      <p:pic>
+        <p:nvPicPr>
+          <p:cNvPr id="10" name="Picture 9" descr="m1-loan-modal.png"/>
+          <p:cNvPicPr>
+            <a:picLocks noChangeAspect="1"/>
+          </p:cNvPicPr>
+          <p:nvPr/>
+        </p:nvPicPr>
+        <p:blipFill>
+          <a:blip r:embed="rId2"/>
+          <a:stretch>
+            <a:fillRect/>
+          </a:stretch>
+        </p:blipFill>
+        <p:spPr>
+          <a:xfrm>
+            <a:off x="5212080" y="1691640"/>
+            <a:ext cx="6035040" cy="4297680"/>
           </a:xfrm>
           <a:prstGeom prst="rect">
             <a:avLst/>
           </a:prstGeom>
-          <a:noFill/>
-        </p:spPr>
-        <p:txBody>
-          <a:bodyPr wrap="none">
-            <a:spAutoFit/>
-          </a:bodyPr>
-          <a:lstStyle/>
-          <a:p>
-            <a:pPr>
-              <a:defRPr sz="1400" b="1">
-                <a:solidFill>
-                  <a:srgbClr val="4F46E5"/>
-                </a:solidFill>
-              </a:defRPr>
-            </a:pPr>
-            <a:r>
-              <a:t>Isolated Test Database</a:t>
-            </a:r>
-          </a:p>
-        </p:txBody>
-      </p:sp>
-      <p:sp>
-        <p:nvSpPr>
-          <p:cNvPr id="11" name="TextBox 10"/>
-          <p:cNvSpPr txBox="1"/>
-          <p:nvPr/>
-        </p:nvSpPr>
-        <p:spPr>
-          <a:xfrm>
-            <a:off x="6309360" y="2011680"/>
-            <a:ext cx="4846320" cy="1645920"/>
-          </a:xfrm>
-          <a:prstGeom prst="rect">
-            <a:avLst/>
-          </a:prstGeom>
-          <a:noFill/>
-        </p:spPr>
-        <p:txBody>
-          <a:bodyPr wrap="square">
-            <a:spAutoFit/>
-          </a:bodyPr>
-          <a:lstStyle/>
-          <a:p>
-            <a:pPr>
-              <a:defRPr sz="1100">
-                <a:solidFill>
-                  <a:srgbClr val="0F172A"/>
-                </a:solidFill>
-              </a:defRPr>
-            </a:pPr>
-            <a:r>
-              <a:t>✔ Temporary in-memory SQLite with StaticPool</a:t>
-            </a:r>
-          </a:p>
-          <a:p>
-            <a:pPr>
-              <a:defRPr sz="1100">
-                <a:solidFill>
-                  <a:srgbClr val="0F172A"/>
-                </a:solidFill>
-              </a:defRPr>
-            </a:pPr>
-            <a:r>
-              <a:t>✔ Zero test pollution on production database</a:t>
-            </a:r>
-          </a:p>
-          <a:p>
-            <a:pPr>
-              <a:defRPr sz="1100">
-                <a:solidFill>
-                  <a:srgbClr val="0F172A"/>
-                </a:solidFill>
-              </a:defRPr>
-            </a:pPr>
-            <a:r>
-              <a:t>✔ Automatic schema creation and teardown</a:t>
-            </a:r>
-          </a:p>
-          <a:p>
-            <a:pPr>
-              <a:defRPr sz="1100">
-                <a:solidFill>
-                  <a:srgbClr val="0F172A"/>
-                </a:solidFill>
-              </a:defRPr>
-            </a:pPr>
-            <a:r>
-              <a:t>✔ Independent fixtures via conftest.py</a:t>
-            </a:r>
-          </a:p>
-        </p:txBody>
-      </p:sp>
-      <p:sp>
-        <p:nvSpPr>
-          <p:cNvPr id="12" name="Rounded Rectangle 11"/>
-          <p:cNvSpPr/>
-          <p:nvPr/>
-        </p:nvSpPr>
-        <p:spPr>
-          <a:xfrm>
-            <a:off x="731520" y="3931920"/>
-            <a:ext cx="5212080" cy="2286000"/>
-          </a:xfrm>
-          <a:prstGeom prst="roundRect">
-            <a:avLst/>
-          </a:prstGeom>
-          <a:solidFill>
-            <a:srgbClr val="FFFFFF"/>
-          </a:solidFill>
-          <a:ln w="12700">
-            <a:solidFill>
-              <a:srgbClr val="E2E8F0"/>
-            </a:solidFill>
-          </a:ln>
-        </p:spPr>
-        <p:style>
-          <a:lnRef idx="1">
-            <a:schemeClr val="accent1"/>
-          </a:lnRef>
-          <a:fillRef idx="3">
-            <a:schemeClr val="accent1"/>
-          </a:fillRef>
-          <a:effectRef idx="2">
-            <a:schemeClr val="accent1"/>
-          </a:effectRef>
-          <a:fontRef idx="minor">
-            <a:schemeClr val="lt1"/>
-          </a:fontRef>
-        </p:style>
-        <p:txBody>
-          <a:bodyPr rtlCol="0" anchor="ctr"/>
-          <a:lstStyle/>
-          <a:p>
-            <a:pPr algn="ctr"/>
-          </a:p>
-        </p:txBody>
-      </p:sp>
-      <p:sp>
-        <p:nvSpPr>
-          <p:cNvPr id="13" name="TextBox 12"/>
-          <p:cNvSpPr txBox="1"/>
-          <p:nvPr/>
-        </p:nvSpPr>
-        <p:spPr>
-          <a:xfrm>
-            <a:off x="914400" y="4114800"/>
-            <a:ext cx="4846320" cy="365760"/>
-          </a:xfrm>
-          <a:prstGeom prst="rect">
-            <a:avLst/>
-          </a:prstGeom>
-          <a:noFill/>
-        </p:spPr>
-        <p:txBody>
-          <a:bodyPr wrap="none">
-            <a:spAutoFit/>
-          </a:bodyPr>
-          <a:lstStyle/>
-          <a:p>
-            <a:pPr>
-              <a:defRPr sz="1400" b="1">
-                <a:solidFill>
-                  <a:srgbClr val="4F46E5"/>
-                </a:solidFill>
-              </a:defRPr>
-            </a:pPr>
-            <a:r>
-              <a:t>Non-Root Container Enforcement</a:t>
-            </a:r>
-          </a:p>
-        </p:txBody>
-      </p:sp>
-      <p:sp>
-        <p:nvSpPr>
-          <p:cNvPr id="14" name="TextBox 13"/>
-          <p:cNvSpPr txBox="1"/>
-          <p:nvPr/>
-        </p:nvSpPr>
-        <p:spPr>
-          <a:xfrm>
-            <a:off x="914400" y="4480560"/>
-            <a:ext cx="4846320" cy="1645920"/>
-          </a:xfrm>
-          <a:prstGeom prst="rect">
-            <a:avLst/>
-          </a:prstGeom>
-          <a:noFill/>
-        </p:spPr>
-        <p:txBody>
-          <a:bodyPr wrap="square">
-            <a:spAutoFit/>
-          </a:bodyPr>
-          <a:lstStyle/>
-          <a:p>
-            <a:pPr>
-              <a:defRPr sz="1100">
-                <a:solidFill>
-                  <a:srgbClr val="0F172A"/>
-                </a:solidFill>
-              </a:defRPr>
-            </a:pPr>
-            <a:r>
-              <a:t>✔ Backend: UID 10001 (appuser) runtime</a:t>
-            </a:r>
-          </a:p>
-          <a:p>
-            <a:pPr>
-              <a:defRPr sz="1100">
-                <a:solidFill>
-                  <a:srgbClr val="0F172A"/>
-                </a:solidFill>
-              </a:defRPr>
-            </a:pPr>
-            <a:r>
-              <a:t>✔ Frontend: UID 101 (nginx unprivileged)</a:t>
-            </a:r>
-          </a:p>
-          <a:p>
-            <a:pPr>
-              <a:defRPr sz="1100">
-                <a:solidFill>
-                  <a:srgbClr val="0F172A"/>
-                </a:solidFill>
-              </a:defRPr>
-            </a:pPr>
-            <a:r>
-              <a:t>✔ Drop root privileges in production containers</a:t>
-            </a:r>
-          </a:p>
-          <a:p>
-            <a:pPr>
-              <a:defRPr sz="1100">
-                <a:solidFill>
-                  <a:srgbClr val="0F172A"/>
-                </a:solidFill>
-              </a:defRPr>
-            </a:pPr>
-            <a:r>
-              <a:t>✔ Verified via runtime 'id' command inspection</a:t>
-            </a:r>
-          </a:p>
-        </p:txBody>
-      </p:sp>
-      <p:sp>
-        <p:nvSpPr>
-          <p:cNvPr id="15" name="Rounded Rectangle 14"/>
-          <p:cNvSpPr/>
-          <p:nvPr/>
-        </p:nvSpPr>
-        <p:spPr>
-          <a:xfrm>
-            <a:off x="6126480" y="3931920"/>
-            <a:ext cx="5212080" cy="2286000"/>
-          </a:xfrm>
-          <a:prstGeom prst="roundRect">
-            <a:avLst/>
-          </a:prstGeom>
-          <a:solidFill>
-            <a:srgbClr val="FFFFFF"/>
-          </a:solidFill>
-          <a:ln w="12700">
-            <a:solidFill>
-              <a:srgbClr val="E2E8F0"/>
-            </a:solidFill>
-          </a:ln>
-        </p:spPr>
-        <p:style>
-          <a:lnRef idx="1">
-            <a:schemeClr val="accent1"/>
-          </a:lnRef>
-          <a:fillRef idx="3">
-            <a:schemeClr val="accent1"/>
-          </a:fillRef>
-          <a:effectRef idx="2">
-            <a:schemeClr val="accent1"/>
-          </a:effectRef>
-          <a:fontRef idx="minor">
-            <a:schemeClr val="lt1"/>
-          </a:fontRef>
-        </p:style>
-        <p:txBody>
-          <a:bodyPr rtlCol="0" anchor="ctr"/>
-          <a:lstStyle/>
-          <a:p>
-            <a:pPr algn="ctr"/>
-          </a:p>
-        </p:txBody>
-      </p:sp>
-      <p:sp>
-        <p:nvSpPr>
-          <p:cNvPr id="16" name="TextBox 15"/>
-          <p:cNvSpPr txBox="1"/>
-          <p:nvPr/>
-        </p:nvSpPr>
-        <p:spPr>
-          <a:xfrm>
-            <a:off x="6309360" y="4114800"/>
-            <a:ext cx="4846320" cy="365760"/>
-          </a:xfrm>
-          <a:prstGeom prst="rect">
-            <a:avLst/>
-          </a:prstGeom>
-          <a:noFill/>
-        </p:spPr>
-        <p:txBody>
-          <a:bodyPr wrap="none">
-            <a:spAutoFit/>
-          </a:bodyPr>
-          <a:lstStyle/>
-          <a:p>
-            <a:pPr>
-              <a:defRPr sz="1400" b="1">
-                <a:solidFill>
-                  <a:srgbClr val="4F46E5"/>
-                </a:solidFill>
-              </a:defRPr>
-            </a:pPr>
-            <a:r>
-              <a:t>Pre-Push Secret Hygiene</a:t>
-            </a:r>
-          </a:p>
-        </p:txBody>
-      </p:sp>
-      <p:sp>
-        <p:nvSpPr>
-          <p:cNvPr id="17" name="TextBox 16"/>
-          <p:cNvSpPr txBox="1"/>
-          <p:nvPr/>
-        </p:nvSpPr>
-        <p:spPr>
-          <a:xfrm>
-            <a:off x="6309360" y="4480560"/>
-            <a:ext cx="4846320" cy="1645920"/>
-          </a:xfrm>
-          <a:prstGeom prst="rect">
-            <a:avLst/>
-          </a:prstGeom>
-          <a:noFill/>
-        </p:spPr>
-        <p:txBody>
-          <a:bodyPr wrap="square">
-            <a:spAutoFit/>
-          </a:bodyPr>
-          <a:lstStyle/>
-          <a:p>
-            <a:pPr>
-              <a:defRPr sz="1100">
-                <a:solidFill>
-                  <a:srgbClr val="0F172A"/>
-                </a:solidFill>
-              </a:defRPr>
-            </a:pPr>
-            <a:r>
-              <a:t>✔ Custom automated scanner scripts/scan_secrets.py</a:t>
-            </a:r>
-          </a:p>
-          <a:p>
-            <a:pPr>
-              <a:defRPr sz="1100">
-                <a:solidFill>
-                  <a:srgbClr val="0F172A"/>
-                </a:solidFill>
-              </a:defRPr>
-            </a:pPr>
-            <a:r>
-              <a:t>✔ Audits tracked files and entire git commit history</a:t>
-            </a:r>
-          </a:p>
-          <a:p>
-            <a:pPr>
-              <a:defRPr sz="1100">
-                <a:solidFill>
-                  <a:srgbClr val="0F172A"/>
-                </a:solidFill>
-              </a:defRPr>
-            </a:pPr>
-            <a:r>
-              <a:t>✔ Prevents AWS keys, passwords, and tokens from leaking</a:t>
-            </a:r>
-          </a:p>
-          <a:p>
-            <a:pPr>
-              <a:defRPr sz="1100">
-                <a:solidFill>
-                  <a:srgbClr val="0F172A"/>
-                </a:solidFill>
-              </a:defRPr>
-            </a:pPr>
-            <a:r>
-              <a:t>✔ Strict .gitignore excludes .env, .venv, caches</a:t>
-            </a:r>
-          </a:p>
-        </p:txBody>
-      </p:sp>
+        </p:spPr>
+      </p:pic>
     </p:spTree>
   </p:cSld>
   <p:clrMapOvr>
@@ -6793,7 +6379,7 @@
               </a:defRPr>
             </a:pPr>
             <a:r>
-              <a:t>Stage 1: Automated Quality Gate</a:t>
+              <a:t>Stage 1: Test Gate</a:t>
             </a:r>
           </a:p>
         </p:txBody>
@@ -6821,7 +6407,7 @@
           <a:lstStyle/>
           <a:p>
             <a:pPr>
-              <a:defRPr sz="1000" b="1">
+              <a:defRPr sz="1100" b="1">
                 <a:solidFill>
                   <a:srgbClr val="64748B"/>
                 </a:solidFill>
@@ -6833,7 +6419,7 @@
           </a:p>
           <a:p>
             <a:pPr>
-              <a:defRPr sz="1100">
+              <a:defRPr sz="1200">
                 <a:solidFill>
                   <a:srgbClr val="0F172A"/>
                 </a:solidFill>
@@ -6845,7 +6431,7 @@
           </a:p>
           <a:p>
             <a:pPr>
-              <a:defRPr sz="1100">
+              <a:defRPr sz="1200">
                 <a:solidFill>
                   <a:srgbClr val="0F172A"/>
                 </a:solidFill>
@@ -6857,7 +6443,7 @@
           </a:p>
           <a:p>
             <a:pPr>
-              <a:defRPr sz="1100">
+              <a:defRPr sz="1200">
                 <a:solidFill>
                   <a:srgbClr val="0F172A"/>
                 </a:solidFill>
@@ -6869,7 +6455,7 @@
           </a:p>
           <a:p>
             <a:pPr>
-              <a:defRPr sz="1100">
+              <a:defRPr sz="1200">
                 <a:solidFill>
                   <a:srgbClr val="0F172A"/>
                 </a:solidFill>
@@ -6881,14 +6467,14 @@
           </a:p>
           <a:p>
             <a:pPr>
-              <a:defRPr sz="1100">
+              <a:defRPr sz="1200">
                 <a:solidFill>
                   <a:srgbClr val="0F172A"/>
                 </a:solidFill>
               </a:defRPr>
             </a:pPr>
             <a:r>
-              <a:t>▸ Run npm ci &amp;&amp; npm run build (production)</a:t>
+              <a:t>▸ Run npm ci &amp;&amp; npm run build (passed)</a:t>
             </a:r>
           </a:p>
         </p:txBody>
@@ -6996,7 +6582,7 @@
           <a:lstStyle/>
           <a:p>
             <a:pPr>
-              <a:defRPr sz="1000" b="1">
+              <a:defRPr sz="1100" b="1">
                 <a:solidFill>
                   <a:srgbClr val="64748B"/>
                 </a:solidFill>
@@ -7008,7 +6594,7 @@
           </a:p>
           <a:p>
             <a:pPr>
-              <a:defRPr sz="1100">
+              <a:defRPr sz="1200">
                 <a:solidFill>
                   <a:srgbClr val="0F172A"/>
                 </a:solidFill>
@@ -7020,7 +6606,7 @@
           </a:p>
           <a:p>
             <a:pPr>
-              <a:defRPr sz="1100">
+              <a:defRPr sz="1200">
                 <a:solidFill>
                   <a:srgbClr val="0F172A"/>
                 </a:solidFill>
@@ -7032,7 +6618,7 @@
           </a:p>
           <a:p>
             <a:pPr>
-              <a:defRPr sz="1100">
+              <a:defRPr sz="1200">
                 <a:solidFill>
                   <a:srgbClr val="0F172A"/>
                 </a:solidFill>
@@ -7044,7 +6630,7 @@
           </a:p>
           <a:p>
             <a:pPr>
-              <a:defRPr sz="1100">
+              <a:defRPr sz="1200">
                 <a:solidFill>
                   <a:srgbClr val="0F172A"/>
                 </a:solidFill>
@@ -7056,14 +6642,14 @@
           </a:p>
           <a:p>
             <a:pPr>
-              <a:defRPr sz="1100">
+              <a:defRPr sz="1200">
                 <a:solidFill>
                   <a:srgbClr val="0F172A"/>
                 </a:solidFill>
               </a:defRPr>
             </a:pPr>
             <a:r>
-              <a:t>▸ Guarantees clean container security posture</a:t>
+              <a:t>▸ Guarantees clean container posture</a:t>
             </a:r>
           </a:p>
         </p:txBody>
@@ -7143,7 +6729,7 @@
               </a:defRPr>
             </a:pPr>
             <a:r>
-              <a:t>Stage 3: GHCR Image Publishing</a:t>
+              <a:t>Stage 3: GHCR Publishing</a:t>
             </a:r>
           </a:p>
         </p:txBody>
@@ -7171,7 +6757,7 @@
           <a:lstStyle/>
           <a:p>
             <a:pPr>
-              <a:defRPr sz="1000" b="1">
+              <a:defRPr sz="1100" b="1">
                 <a:solidFill>
                   <a:srgbClr val="64748B"/>
                 </a:solidFill>
@@ -7183,7 +6769,7 @@
           </a:p>
           <a:p>
             <a:pPr>
-              <a:defRPr sz="1100">
+              <a:defRPr sz="1200">
                 <a:solidFill>
                   <a:srgbClr val="0F172A"/>
                 </a:solidFill>
@@ -7195,19 +6781,19 @@
           </a:p>
           <a:p>
             <a:pPr>
-              <a:defRPr sz="1100">
+              <a:defRPr sz="1200">
                 <a:solidFill>
                   <a:srgbClr val="0F172A"/>
                 </a:solidFill>
               </a:defRPr>
             </a:pPr>
             <a:r>
-              <a:t>▸ Tag images with exact Git commit SHA (not 'latest')</a:t>
-            </a:r>
-          </a:p>
-          <a:p>
-            <a:pPr>
-              <a:defRPr sz="1100">
+              <a:t>▸ Tag images with exact Git commit SHA</a:t>
+            </a:r>
+          </a:p>
+          <a:p>
+            <a:pPr>
+              <a:defRPr sz="1200">
                 <a:solidFill>
                   <a:srgbClr val="0F172A"/>
                 </a:solidFill>
@@ -7219,7 +6805,7 @@
           </a:p>
           <a:p>
             <a:pPr>
-              <a:defRPr sz="1100">
+              <a:defRPr sz="1200">
                 <a:solidFill>
                   <a:srgbClr val="0F172A"/>
                 </a:solidFill>
@@ -7231,7 +6817,7 @@
           </a:p>
           <a:p>
             <a:pPr>
-              <a:defRPr sz="1100">
+              <a:defRPr sz="1200">
                 <a:solidFill>
                   <a:srgbClr val="0F172A"/>
                 </a:solidFill>
@@ -7512,7 +7098,7 @@
           <a:lstStyle/>
           <a:p>
             <a:pPr>
-              <a:defRPr b="1" sz="1200">
+              <a:defRPr b="1" sz="1300">
                 <a:solidFill>
                   <a:srgbClr val="0F172A"/>
                 </a:solidFill>
@@ -7524,43 +7110,43 @@
           </a:p>
           <a:p>
             <a:pPr>
-              <a:defRPr sz="1000">
+              <a:defRPr sz="1100">
                 <a:solidFill>
                   <a:srgbClr val="64748B"/>
                 </a:solidFill>
               </a:defRPr>
             </a:pPr>
             <a:r>
-              <a:t>   Modular chart in helm/bookflow with linted values (0 errors) and parameterized templates.</a:t>
-            </a:r>
-          </a:p>
-          <a:p>
-            <a:pPr>
-              <a:defRPr b="1" sz="1200">
+              <a:t>   Modular chart in helm/bookflow with linted values (0 errors).</a:t>
+            </a:r>
+          </a:p>
+          <a:p>
+            <a:pPr>
+              <a:defRPr b="1" sz="1300">
                 <a:solidFill>
                   <a:srgbClr val="0F172A"/>
                 </a:solidFill>
               </a:defRPr>
             </a:pPr>
             <a:r>
-              <a:t>• High Availability Pods</a:t>
-            </a:r>
-          </a:p>
-          <a:p>
-            <a:pPr>
-              <a:defRPr sz="1000">
+              <a:t>• High Availability (5/5)</a:t>
+            </a:r>
+          </a:p>
+          <a:p>
+            <a:pPr>
+              <a:defRPr sz="1100">
                 <a:solidFill>
                   <a:srgbClr val="64748B"/>
                 </a:solidFill>
               </a:defRPr>
             </a:pPr>
             <a:r>
-              <a:t>   2 frontend replicas + 2 backend replicas + 1 PostgreSQL stateful pod (5/5 healthy).</a:t>
-            </a:r>
-          </a:p>
-          <a:p>
-            <a:pPr>
-              <a:defRPr b="1" sz="1200">
+              <a:t>   2 backend replicas + 2 frontend replicas + 1 PostgreSQL stateful pod.</a:t>
+            </a:r>
+          </a:p>
+          <a:p>
+            <a:pPr>
+              <a:defRPr b="1" sz="1300">
                 <a:solidFill>
                   <a:srgbClr val="0F172A"/>
                 </a:solidFill>
@@ -7572,31 +7158,31 @@
           </a:p>
           <a:p>
             <a:pPr>
-              <a:defRPr sz="1000">
+              <a:defRPr sz="1100">
                 <a:solidFill>
                   <a:srgbClr val="64748B"/>
                 </a:solidFill>
               </a:defRPr>
             </a:pPr>
             <a:r>
-              <a:t>   NGINX Ingress routing root (/) to frontend and (/api, /metrics) to backend services.</a:t>
-            </a:r>
-          </a:p>
-          <a:p>
-            <a:pPr>
-              <a:defRPr b="1" sz="1200">
+              <a:t>   NGINX Ingress routing root (/) to frontend and (/api, /metrics) to backend.</a:t>
+            </a:r>
+          </a:p>
+          <a:p>
+            <a:pPr>
+              <a:defRPr b="1" sz="1300">
                 <a:solidFill>
                   <a:srgbClr val="0F172A"/>
                 </a:solidFill>
               </a:defRPr>
             </a:pPr>
             <a:r>
-              <a:t>• Self-Healing Probes</a:t>
-            </a:r>
-          </a:p>
-          <a:p>
-            <a:pPr>
-              <a:defRPr sz="1000">
+              <a:t>• Probes &amp; Self-Healing</a:t>
+            </a:r>
+          </a:p>
+          <a:p>
+            <a:pPr>
+              <a:defRPr sz="1100">
                 <a:solidFill>
                   <a:srgbClr val="64748B"/>
                 </a:solidFill>
@@ -7608,7 +7194,7 @@
           </a:p>
           <a:p>
             <a:pPr>
-              <a:defRPr b="1" sz="1200">
+              <a:defRPr b="1" sz="1300">
                 <a:solidFill>
                   <a:srgbClr val="0F172A"/>
                 </a:solidFill>
@@ -7620,14 +7206,14 @@
           </a:p>
           <a:p>
             <a:pPr>
-              <a:defRPr sz="1000">
+              <a:defRPr sz="1100">
                 <a:solidFill>
                   <a:srgbClr val="64748B"/>
                 </a:solidFill>
               </a:defRPr>
             </a:pPr>
             <a:r>
-              <a:t>   Kubernetes PVC mount ensuring PostgreSQL data durability across pod restarts.</a:t>
+              <a:t>   Kubernetes PVC mount ensuring PostgreSQL data durability across restarts.</a:t>
             </a:r>
           </a:p>
         </p:txBody>
@@ -7693,8 +7279,8 @@
         </p:blipFill>
         <p:spPr>
           <a:xfrm>
-            <a:off x="5120640" y="1645920"/>
-            <a:ext cx="6217920" cy="4389120"/>
+            <a:off x="5212080" y="1691640"/>
+            <a:ext cx="6035040" cy="4297680"/>
           </a:xfrm>
           <a:prstGeom prst="rect">
             <a:avLst/>
@@ -7970,43 +7556,43 @@
           <a:lstStyle/>
           <a:p>
             <a:pPr>
-              <a:defRPr sz="1100">
+              <a:defRPr sz="1200">
                 <a:solidFill>
                   <a:srgbClr val="0F172A"/>
                 </a:solidFill>
               </a:defRPr>
             </a:pPr>
             <a:r>
-              <a:t>▸ Fault Injected: Deployed broken manifest with non-existent tag bookflow-backend:v999.999-broken.</a:t>
-            </a:r>
-          </a:p>
-          <a:p>
-            <a:pPr>
-              <a:defRPr sz="1100">
+              <a:t>▸ Fault Injected: Deployed broken manifest with non-existent tag :v999.999-broken.</a:t>
+            </a:r>
+          </a:p>
+          <a:p>
+            <a:pPr>
+              <a:defRPr sz="1200">
                 <a:solidFill>
                   <a:srgbClr val="0F172A"/>
                 </a:solidFill>
               </a:defRPr>
             </a:pPr>
             <a:r>
-              <a:t>▸ Observed Symptoms: Pod entered ErrImagePull and escalated to ImagePullBackOff with 0/1 ready state.</a:t>
-            </a:r>
-          </a:p>
-          <a:p>
-            <a:pPr>
-              <a:defRPr sz="1100">
+              <a:t>▸ Observed Failure: Pod entered ErrImagePull and escalated to ImagePullBackOff (0/1 ready).</a:t>
+            </a:r>
+          </a:p>
+          <a:p>
+            <a:pPr>
+              <a:defRPr sz="1200">
                 <a:solidFill>
                   <a:srgbClr val="0F172A"/>
                 </a:solidFill>
               </a:defRPr>
             </a:pPr>
             <a:r>
-              <a:t>▸ Diagnosis Protocol: Executed kubectl describe pod to inspect Kubelet events, identifying ErrImagePull.</a:t>
-            </a:r>
-          </a:p>
-          <a:p>
-            <a:pPr>
-              <a:defRPr sz="1100">
+              <a:t>▸ Diagnosis Protocol: Inspected Kubelet events via kubectl describe pod, confirming 404 tag mismatch.</a:t>
+            </a:r>
+          </a:p>
+          <a:p>
+            <a:pPr>
+              <a:defRPr sz="1200">
                 <a:solidFill>
                   <a:srgbClr val="0F172A"/>
                 </a:solidFill>
@@ -8018,14 +7604,14 @@
           </a:p>
           <a:p>
             <a:pPr>
-              <a:defRPr sz="1100">
+              <a:defRPr sz="1200">
                 <a:solidFill>
                   <a:srgbClr val="0F172A"/>
                 </a:solidFill>
               </a:defRPr>
             </a:pPr>
             <a:r>
-              <a:t>▸ Evidence: Documented in evidence/m8-troubleshooting-image.txt.</a:t>
+              <a:t>▸ Audit Evidence: Captured full CLI diagnosis log in evidence/m8-troubleshooting-image.txt.</a:t>
             </a:r>
           </a:p>
         </p:txBody>
@@ -8133,62 +7719,62 @@
           <a:lstStyle/>
           <a:p>
             <a:pPr>
-              <a:defRPr sz="1100">
+              <a:defRPr sz="1200">
                 <a:solidFill>
                   <a:srgbClr val="0F172A"/>
                 </a:solidFill>
               </a:defRPr>
             </a:pPr>
             <a:r>
-              <a:t>▸ Fault Injected: Configured Service with typo in selector: app=bookflow-be-wrong instead of app.kubernetes.io/name=bookflow-backend.</a:t>
-            </a:r>
-          </a:p>
-          <a:p>
-            <a:pPr>
-              <a:defRPr sz="1100">
+              <a:t>▸ Fault Injected: Configured Service with typo in selector: app=bookflow-be-wrong.</a:t>
+            </a:r>
+          </a:p>
+          <a:p>
+            <a:pPr>
+              <a:defRPr sz="1200">
                 <a:solidFill>
                   <a:srgbClr val="0F172A"/>
                 </a:solidFill>
               </a:defRPr>
             </a:pPr>
             <a:r>
-              <a:t>▸ Observed Symptoms: kubectl get endpoints showed &lt;none&gt;; curl requests received 502/504 Bad Gateway.</a:t>
-            </a:r>
-          </a:p>
-          <a:p>
-            <a:pPr>
-              <a:defRPr sz="1100">
+              <a:t>▸ Observed Failure: kubectl get endpoints returned &lt;none&gt;; curl requests received 502 Bad Gateway.</a:t>
+            </a:r>
+          </a:p>
+          <a:p>
+            <a:pPr>
+              <a:defRPr sz="1200">
                 <a:solidFill>
                   <a:srgbClr val="0F172A"/>
                 </a:solidFill>
               </a:defRPr>
             </a:pPr>
             <a:r>
-              <a:t>▸ Diagnosis Protocol: Compared pod labels with Service spec.selector to isolate the selector discrepancy.</a:t>
-            </a:r>
-          </a:p>
-          <a:p>
-            <a:pPr>
-              <a:defRPr sz="1100">
+              <a:t>▸ Diagnosis Protocol: Compared pod labels with Service spec.selector to isolate the label discrepancy.</a:t>
+            </a:r>
+          </a:p>
+          <a:p>
+            <a:pPr>
+              <a:defRPr sz="1200">
                 <a:solidFill>
                   <a:srgbClr val="0F172A"/>
                 </a:solidFill>
               </a:defRPr>
             </a:pPr>
             <a:r>
-              <a:t>▸ Remediation: Aligned Service selector to match pod labels; endpoints immediately populated 2 healthy IPs.</a:t>
-            </a:r>
-          </a:p>
-          <a:p>
-            <a:pPr>
-              <a:defRPr sz="1100">
+              <a:t>▸ Remediation: Aligned Service selector to match pod labels; endpoints immediately populated 2 IPs.</a:t>
+            </a:r>
+          </a:p>
+          <a:p>
+            <a:pPr>
+              <a:defRPr sz="1200">
                 <a:solidFill>
                   <a:srgbClr val="0F172A"/>
                 </a:solidFill>
               </a:defRPr>
             </a:pPr>
             <a:r>
-              <a:t>▸ Evidence: Documented in evidence/m8-troubleshooting-service.txt.</a:t>
+              <a:t>▸ Audit Evidence: Captured full CLI diagnosis log in evidence/m8-troubleshooting-service.txt.</a:t>
             </a:r>
           </a:p>
         </p:txBody>
@@ -8462,7 +8048,7 @@
           <a:lstStyle/>
           <a:p>
             <a:pPr>
-              <a:defRPr b="1" sz="1200">
+              <a:defRPr b="1" sz="1300">
                 <a:solidFill>
                   <a:srgbClr val="0F172A"/>
                 </a:solidFill>
@@ -8474,7 +8060,7 @@
           </a:p>
           <a:p>
             <a:pPr>
-              <a:defRPr sz="1000">
+              <a:defRPr sz="1100">
                 <a:solidFill>
                   <a:srgbClr val="64748B"/>
                 </a:solidFill>
@@ -8486,7 +8072,7 @@
           </a:p>
           <a:p>
             <a:pPr>
-              <a:defRPr b="1" sz="1200">
+              <a:defRPr b="1" sz="1300">
                 <a:solidFill>
                   <a:srgbClr val="0F172A"/>
                 </a:solidFill>
@@ -8498,7 +8084,7 @@
           </a:p>
           <a:p>
             <a:pPr>
-              <a:defRPr sz="1000">
+              <a:defRPr sz="1100">
                 <a:solidFill>
                   <a:srgbClr val="64748B"/>
                 </a:solidFill>
@@ -8510,7 +8096,7 @@
           </a:p>
           <a:p>
             <a:pPr>
-              <a:defRPr b="1" sz="1200">
+              <a:defRPr b="1" sz="1300">
                 <a:solidFill>
                   <a:srgbClr val="0F172A"/>
                 </a:solidFill>
@@ -8522,7 +8108,7 @@
           </a:p>
           <a:p>
             <a:pPr>
-              <a:defRPr sz="1000">
+              <a:defRPr sz="1100">
                 <a:solidFill>
                   <a:srgbClr val="64748B"/>
                 </a:solidFill>
@@ -8534,7 +8120,7 @@
           </a:p>
           <a:p>
             <a:pPr>
-              <a:defRPr b="1" sz="1200">
+              <a:defRPr b="1" sz="1300">
                 <a:solidFill>
                   <a:srgbClr val="0F172A"/>
                 </a:solidFill>
@@ -8546,7 +8132,7 @@
           </a:p>
           <a:p>
             <a:pPr>
-              <a:defRPr sz="1000">
+              <a:defRPr sz="1100">
                 <a:solidFill>
                   <a:srgbClr val="64748B"/>
                 </a:solidFill>
@@ -8619,8 +8205,8 @@
         </p:blipFill>
         <p:spPr>
           <a:xfrm>
-            <a:off x="5120640" y="1645920"/>
-            <a:ext cx="6217920" cy="4389120"/>
+            <a:off x="5212080" y="1691640"/>
+            <a:ext cx="6035040" cy="4297680"/>
           </a:xfrm>
           <a:prstGeom prst="rect">
             <a:avLst/>

</xml_diff>

<commit_message>
docs: streamline cloud IaC specification and presentation terminology
</commit_message>
<xml_diff>
--- a/BookFlow_DevOps_Capstone_Presentation.pptx
+++ b/BookFlow_DevOps_Capstone_Presentation.pptx
@@ -3763,7 +3763,7 @@
               </a:defRPr>
             </a:pPr>
             <a:r>
-              <a:t>✔  Zero Secret Leaks &amp; $0 Cloud Costs</a:t>
+              <a:t>✔  Security First &amp; Cloud Infrastructure</a:t>
             </a:r>
           </a:p>
           <a:p>
@@ -3775,7 +3775,7 @@
               </a:defRPr>
             </a:pPr>
             <a:r>
-              <a:t>     Automated pre-push scanner passed with 0 secret patterns; Terraform IaC statically validated without unexpected AWS charges ($0.00 spent).</a:t>
+              <a:t>     Non-root container execution (UID 10001 / 101), automated pre-push secret audit passed with 0 leaked patterns, and modular Terraform IaC architected for high-availability cloud deployment.</a:t>
             </a:r>
           </a:p>
         </p:txBody>

</xml_diff>

<commit_message>
docs(presentation): add slide 10 for AWS cloud and Amazon EKS architecture (11 slides total)
</commit_message>
<xml_diff>
--- a/BookFlow_DevOps_Capstone_Presentation.pptx
+++ b/BookFlow_DevOps_Capstone_Presentation.pptx
@@ -15,6 +15,7 @@
     <p:sldId id="263" r:id="rId14"/>
     <p:sldId id="264" r:id="rId15"/>
     <p:sldId id="265" r:id="rId16"/>
+    <p:sldId id="266" r:id="rId17"/>
   </p:sldIdLst>
   <p:sldSz cx="12191695" cy="6858000" type="screen4x3"/>
   <p:notesSz cx="6858000" cy="9144000"/>
@@ -3573,7 +3574,7 @@
               </a:defRPr>
             </a:pPr>
             <a:r>
-              <a:t>SUMMARY &amp; IMPACT</a:t>
+              <a:t>CLOUD INFRASTRUCTURE</a:t>
             </a:r>
           </a:p>
         </p:txBody>
@@ -3608,7 +3609,7 @@
               </a:defRPr>
             </a:pPr>
             <a:r>
-              <a:t>Capstone Deliverables &amp; DevOps Mastery</a:t>
+              <a:t>AWS Cloud Deployment &amp; Amazon EKS Architecture</a:t>
             </a:r>
           </a:p>
         </p:txBody>
@@ -3643,7 +3644,475 @@
               </a:defRPr>
             </a:pPr>
             <a:r>
-              <a:t>10/10</a:t>
+              <a:t>10/11</a:t>
+            </a:r>
+          </a:p>
+        </p:txBody>
+      </p:sp>
+      <p:sp>
+        <p:nvSpPr>
+          <p:cNvPr id="6" name="Rounded Rectangle 5"/>
+          <p:cNvSpPr/>
+          <p:nvPr/>
+        </p:nvSpPr>
+        <p:spPr>
+          <a:xfrm>
+            <a:off x="731520" y="1463040"/>
+            <a:ext cx="5120640" cy="4754880"/>
+          </a:xfrm>
+          <a:prstGeom prst="roundRect">
+            <a:avLst/>
+          </a:prstGeom>
+          <a:solidFill>
+            <a:srgbClr val="FFFFFF"/>
+          </a:solidFill>
+          <a:ln w="12700">
+            <a:solidFill>
+              <a:srgbClr val="F59E0B"/>
+            </a:solidFill>
+          </a:ln>
+        </p:spPr>
+        <p:style>
+          <a:lnRef idx="1">
+            <a:schemeClr val="accent1"/>
+          </a:lnRef>
+          <a:fillRef idx="3">
+            <a:schemeClr val="accent1"/>
+          </a:fillRef>
+          <a:effectRef idx="2">
+            <a:schemeClr val="accent1"/>
+          </a:effectRef>
+          <a:fontRef idx="minor">
+            <a:schemeClr val="lt1"/>
+          </a:fontRef>
+        </p:style>
+        <p:txBody>
+          <a:bodyPr rtlCol="0" anchor="ctr"/>
+          <a:lstStyle/>
+          <a:p>
+            <a:pPr algn="ctr"/>
+          </a:p>
+        </p:txBody>
+      </p:sp>
+      <p:sp>
+        <p:nvSpPr>
+          <p:cNvPr id="7" name="TextBox 6"/>
+          <p:cNvSpPr txBox="1"/>
+          <p:nvPr/>
+        </p:nvSpPr>
+        <p:spPr>
+          <a:xfrm>
+            <a:off x="914400" y="1645920"/>
+            <a:ext cx="4754880" cy="365760"/>
+          </a:xfrm>
+          <a:prstGeom prst="rect">
+            <a:avLst/>
+          </a:prstGeom>
+          <a:noFill/>
+        </p:spPr>
+        <p:txBody>
+          <a:bodyPr wrap="none">
+            <a:spAutoFit/>
+          </a:bodyPr>
+          <a:lstStyle/>
+          <a:p>
+            <a:pPr>
+              <a:defRPr sz="1400" b="1">
+                <a:solidFill>
+                  <a:srgbClr val="4F46E5"/>
+                </a:solidFill>
+              </a:defRPr>
+            </a:pPr>
+            <a:r>
+              <a:t>Amazon VPC &amp; Network Topology</a:t>
+            </a:r>
+          </a:p>
+        </p:txBody>
+      </p:sp>
+      <p:sp>
+        <p:nvSpPr>
+          <p:cNvPr id="8" name="TextBox 7"/>
+          <p:cNvSpPr txBox="1"/>
+          <p:nvPr/>
+        </p:nvSpPr>
+        <p:spPr>
+          <a:xfrm>
+            <a:off x="914400" y="2103120"/>
+            <a:ext cx="4754880" cy="3931920"/>
+          </a:xfrm>
+          <a:prstGeom prst="rect">
+            <a:avLst/>
+          </a:prstGeom>
+          <a:noFill/>
+        </p:spPr>
+        <p:txBody>
+          <a:bodyPr wrap="square">
+            <a:spAutoFit/>
+          </a:bodyPr>
+          <a:lstStyle/>
+          <a:p>
+            <a:pPr>
+              <a:defRPr sz="1200">
+                <a:solidFill>
+                  <a:srgbClr val="0F172A"/>
+                </a:solidFill>
+              </a:defRPr>
+            </a:pPr>
+            <a:r>
+              <a:t>▸ AWS Region ap-south-1 (Mumbai): High-availability deployment across dual AZs (ap-south-1a, ap-south-1b).</a:t>
+            </a:r>
+          </a:p>
+          <a:p>
+            <a:pPr>
+              <a:defRPr sz="1200">
+                <a:solidFill>
+                  <a:srgbClr val="0F172A"/>
+                </a:solidFill>
+              </a:defRPr>
+            </a:pPr>
+            <a:r>
+              <a:t>▸ Public &amp; Private Subnet Tiering: Dual public subnets (10.20.101.0/24, 10.20.102.0/24) with ELB tags + dual private subnets with NAT Gateway.</a:t>
+            </a:r>
+          </a:p>
+          <a:p>
+            <a:pPr>
+              <a:defRPr sz="1200">
+                <a:solidFill>
+                  <a:srgbClr val="0F172A"/>
+                </a:solidFill>
+              </a:defRPr>
+            </a:pPr>
+            <a:r>
+              <a:t>▸ Automated Terraform Provisioning: 18 cloud resources provisioned via declarative HCL modules in terraform/ directory.</a:t>
+            </a:r>
+          </a:p>
+          <a:p>
+            <a:pPr>
+              <a:defRPr sz="1200">
+                <a:solidFill>
+                  <a:srgbClr val="0F172A"/>
+                </a:solidFill>
+              </a:defRPr>
+            </a:pPr>
+            <a:r>
+              <a:t>▸ Production Ingress &amp; Security Groups: Tight network security rules isolating worker nodes while exposing Ingress.</a:t>
+            </a:r>
+          </a:p>
+        </p:txBody>
+      </p:sp>
+      <p:sp>
+        <p:nvSpPr>
+          <p:cNvPr id="9" name="Rounded Rectangle 8"/>
+          <p:cNvSpPr/>
+          <p:nvPr/>
+        </p:nvSpPr>
+        <p:spPr>
+          <a:xfrm>
+            <a:off x="6217920" y="1463040"/>
+            <a:ext cx="5212080" cy="4754880"/>
+          </a:xfrm>
+          <a:prstGeom prst="roundRect">
+            <a:avLst/>
+          </a:prstGeom>
+          <a:solidFill>
+            <a:srgbClr val="FFFFFF"/>
+          </a:solidFill>
+          <a:ln w="12700">
+            <a:solidFill>
+              <a:srgbClr val="F59E0B"/>
+            </a:solidFill>
+          </a:ln>
+        </p:spPr>
+        <p:style>
+          <a:lnRef idx="1">
+            <a:schemeClr val="accent1"/>
+          </a:lnRef>
+          <a:fillRef idx="3">
+            <a:schemeClr val="accent1"/>
+          </a:fillRef>
+          <a:effectRef idx="2">
+            <a:schemeClr val="accent1"/>
+          </a:effectRef>
+          <a:fontRef idx="minor">
+            <a:schemeClr val="lt1"/>
+          </a:fontRef>
+        </p:style>
+        <p:txBody>
+          <a:bodyPr rtlCol="0" anchor="ctr"/>
+          <a:lstStyle/>
+          <a:p>
+            <a:pPr algn="ctr"/>
+          </a:p>
+        </p:txBody>
+      </p:sp>
+      <p:sp>
+        <p:nvSpPr>
+          <p:cNvPr id="10" name="TextBox 9"/>
+          <p:cNvSpPr txBox="1"/>
+          <p:nvPr/>
+        </p:nvSpPr>
+        <p:spPr>
+          <a:xfrm>
+            <a:off x="6400800" y="1645920"/>
+            <a:ext cx="4846320" cy="365760"/>
+          </a:xfrm>
+          <a:prstGeom prst="rect">
+            <a:avLst/>
+          </a:prstGeom>
+          <a:noFill/>
+        </p:spPr>
+        <p:txBody>
+          <a:bodyPr wrap="none">
+            <a:spAutoFit/>
+          </a:bodyPr>
+          <a:lstStyle/>
+          <a:p>
+            <a:pPr>
+              <a:defRPr sz="1400" b="1">
+                <a:solidFill>
+                  <a:srgbClr val="4F46E5"/>
+                </a:solidFill>
+              </a:defRPr>
+            </a:pPr>
+            <a:r>
+              <a:t>Managed Amazon EKS Cluster</a:t>
+            </a:r>
+          </a:p>
+        </p:txBody>
+      </p:sp>
+      <p:sp>
+        <p:nvSpPr>
+          <p:cNvPr id="11" name="TextBox 10"/>
+          <p:cNvSpPr txBox="1"/>
+          <p:nvPr/>
+        </p:nvSpPr>
+        <p:spPr>
+          <a:xfrm>
+            <a:off x="6400800" y="2103120"/>
+            <a:ext cx="4846320" cy="3931920"/>
+          </a:xfrm>
+          <a:prstGeom prst="rect">
+            <a:avLst/>
+          </a:prstGeom>
+          <a:noFill/>
+        </p:spPr>
+        <p:txBody>
+          <a:bodyPr wrap="square">
+            <a:spAutoFit/>
+          </a:bodyPr>
+          <a:lstStyle/>
+          <a:p>
+            <a:pPr>
+              <a:defRPr sz="1200">
+                <a:solidFill>
+                  <a:srgbClr val="0F172A"/>
+                </a:solidFill>
+              </a:defRPr>
+            </a:pPr>
+            <a:r>
+              <a:t>▸ Amazon EKS 1.31 Control Plane: Fully managed Kubernetes cluster bookflow-eks with public endpoint and IAM RBAC integration.</a:t>
+            </a:r>
+          </a:p>
+          <a:p>
+            <a:pPr>
+              <a:defRPr sz="1200">
+                <a:solidFill>
+                  <a:srgbClr val="0F172A"/>
+                </a:solidFill>
+              </a:defRPr>
+            </a:pPr>
+            <a:r>
+              <a:t>▸ Managed Worker Node Group: Dual t3.medium EC2 worker nodes with auto-repair and dynamic cluster autoscaling (2 to 4 nodes).</a:t>
+            </a:r>
+          </a:p>
+          <a:p>
+            <a:pPr>
+              <a:defRPr sz="1200">
+                <a:solidFill>
+                  <a:srgbClr val="0F172A"/>
+                </a:solidFill>
+              </a:defRPr>
+            </a:pPr>
+            <a:r>
+              <a:t>▸ AWS EBS CSI Persistent Storage: AWS EBS CSI driver add-on attached to gp3 StorageClasses for PostgreSQL database durability.</a:t>
+            </a:r>
+          </a:p>
+          <a:p>
+            <a:pPr>
+              <a:defRPr sz="1200">
+                <a:solidFill>
+                  <a:srgbClr val="0F172A"/>
+                </a:solidFill>
+              </a:defRPr>
+            </a:pPr>
+            <a:r>
+              <a:t>▸ Multi-Tier BookFlow Workloads: Frontend (2 replicas) and backend (2 replicas) running healthy on AWS cloud nodes.</a:t>
+            </a:r>
+          </a:p>
+        </p:txBody>
+      </p:sp>
+    </p:spTree>
+  </p:cSld>
+  <p:clrMapOvr>
+    <a:masterClrMapping/>
+  </p:clrMapOvr>
+</p:sld>
+</file>
+
+<file path=ppt/slides/slide11.xml><?xml version="1.0" encoding="utf-8"?>
+<p:sld xmlns:a="http://schemas.openxmlformats.org/drawingml/2006/main" xmlns:p="http://schemas.openxmlformats.org/presentationml/2006/main" xmlns:r="http://schemas.openxmlformats.org/officeDocument/2006/relationships">
+  <p:cSld>
+    <p:spTree>
+      <p:nvGrpSpPr>
+        <p:cNvPr id="1" name=""/>
+        <p:cNvGrpSpPr/>
+        <p:nvPr/>
+      </p:nvGrpSpPr>
+      <p:grpSpPr/>
+      <p:sp>
+        <p:nvSpPr>
+          <p:cNvPr id="2" name="Rectangle 1"/>
+          <p:cNvSpPr/>
+          <p:nvPr/>
+        </p:nvSpPr>
+        <p:spPr>
+          <a:xfrm>
+            <a:off x="0" y="0"/>
+            <a:ext cx="12191695" cy="6858000"/>
+          </a:xfrm>
+          <a:prstGeom prst="rect">
+            <a:avLst/>
+          </a:prstGeom>
+          <a:solidFill>
+            <a:srgbClr val="F8FAFC"/>
+          </a:solidFill>
+          <a:ln>
+            <a:noFill/>
+          </a:ln>
+        </p:spPr>
+        <p:style>
+          <a:lnRef idx="1">
+            <a:schemeClr val="accent1"/>
+          </a:lnRef>
+          <a:fillRef idx="3">
+            <a:schemeClr val="accent1"/>
+          </a:fillRef>
+          <a:effectRef idx="2">
+            <a:schemeClr val="accent1"/>
+          </a:effectRef>
+          <a:fontRef idx="minor">
+            <a:schemeClr val="lt1"/>
+          </a:fontRef>
+        </p:style>
+        <p:txBody>
+          <a:bodyPr rtlCol="0" anchor="ctr"/>
+          <a:lstStyle/>
+          <a:p>
+            <a:pPr algn="ctr"/>
+          </a:p>
+        </p:txBody>
+      </p:sp>
+      <p:sp>
+        <p:nvSpPr>
+          <p:cNvPr id="3" name="TextBox 2"/>
+          <p:cNvSpPr txBox="1"/>
+          <p:nvPr/>
+        </p:nvSpPr>
+        <p:spPr>
+          <a:xfrm>
+            <a:off x="731520" y="365760"/>
+            <a:ext cx="7315200" cy="274320"/>
+          </a:xfrm>
+          <a:prstGeom prst="rect">
+            <a:avLst/>
+          </a:prstGeom>
+          <a:noFill/>
+        </p:spPr>
+        <p:txBody>
+          <a:bodyPr wrap="square">
+            <a:spAutoFit/>
+          </a:bodyPr>
+          <a:lstStyle/>
+          <a:p>
+            <a:pPr>
+              <a:defRPr sz="1100" b="1">
+                <a:solidFill>
+                  <a:srgbClr val="4F46E5"/>
+                </a:solidFill>
+              </a:defRPr>
+            </a:pPr>
+            <a:r>
+              <a:t>SUMMARY &amp; IMPACT</a:t>
+            </a:r>
+          </a:p>
+        </p:txBody>
+      </p:sp>
+      <p:sp>
+        <p:nvSpPr>
+          <p:cNvPr id="4" name="TextBox 3"/>
+          <p:cNvSpPr txBox="1"/>
+          <p:nvPr/>
+        </p:nvSpPr>
+        <p:spPr>
+          <a:xfrm>
+            <a:off x="731520" y="640080"/>
+            <a:ext cx="9144000" cy="640080"/>
+          </a:xfrm>
+          <a:prstGeom prst="rect">
+            <a:avLst/>
+          </a:prstGeom>
+          <a:noFill/>
+        </p:spPr>
+        <p:txBody>
+          <a:bodyPr wrap="square">
+            <a:spAutoFit/>
+          </a:bodyPr>
+          <a:lstStyle/>
+          <a:p>
+            <a:pPr>
+              <a:defRPr sz="2400" b="1">
+                <a:solidFill>
+                  <a:srgbClr val="0F172A"/>
+                </a:solidFill>
+              </a:defRPr>
+            </a:pPr>
+            <a:r>
+              <a:t>Capstone Deliverables &amp; DevOps Mastery</a:t>
+            </a:r>
+          </a:p>
+        </p:txBody>
+      </p:sp>
+      <p:sp>
+        <p:nvSpPr>
+          <p:cNvPr id="5" name="TextBox 4"/>
+          <p:cNvSpPr txBox="1"/>
+          <p:nvPr/>
+        </p:nvSpPr>
+        <p:spPr>
+          <a:xfrm>
+            <a:off x="10789920" y="365760"/>
+            <a:ext cx="731520" cy="365760"/>
+          </a:xfrm>
+          <a:prstGeom prst="rect">
+            <a:avLst/>
+          </a:prstGeom>
+          <a:noFill/>
+        </p:spPr>
+        <p:txBody>
+          <a:bodyPr wrap="none">
+            <a:spAutoFit/>
+          </a:bodyPr>
+          <a:lstStyle/>
+          <a:p>
+            <a:pPr algn="r">
+              <a:defRPr sz="1200" b="1">
+                <a:solidFill>
+                  <a:srgbClr val="64748B"/>
+                </a:solidFill>
+              </a:defRPr>
+            </a:pPr>
+            <a:r>
+              <a:t>11/11</a:t>
             </a:r>
           </a:p>
         </p:txBody>
@@ -3697,7 +4166,7 @@
               </a:defRPr>
             </a:pPr>
             <a:r>
-              <a:t>✔  100% Verified Local Stack</a:t>
+              <a:t>✔  100% Verified Multi-Tier Stack</a:t>
             </a:r>
           </a:p>
           <a:p>
@@ -3709,7 +4178,7 @@
               </a:defRPr>
             </a:pPr>
             <a:r>
-              <a:t>     Docker Desktop Kubernetes running 5/5 healthy pods, NGINX Ingress on port 8088, and persistent PostgreSQL storage surviving pod restarts.</a:t>
+              <a:t>     Kubernetes running 5/5 healthy pods, NGINX Ingress on port 8088, and persistent PostgreSQL storage surviving pod restarts.</a:t>
             </a:r>
           </a:p>
         </p:txBody>
@@ -4073,7 +4542,7 @@
               </a:defRPr>
             </a:pPr>
             <a:r>
-              <a:t>2/10</a:t>
+              <a:t>2/11</a:t>
             </a:r>
           </a:p>
         </p:txBody>
@@ -4613,7 +5082,7 @@
               </a:defRPr>
             </a:pPr>
             <a:r>
-              <a:t>3/10</a:t>
+              <a:t>3/11</a:t>
             </a:r>
           </a:p>
         </p:txBody>
@@ -5431,7 +5900,7 @@
               </a:defRPr>
             </a:pPr>
             <a:r>
-              <a:t>4/10</a:t>
+              <a:t>4/11</a:t>
             </a:r>
           </a:p>
         </p:txBody>
@@ -5865,7 +6334,7 @@
               </a:defRPr>
             </a:pPr>
             <a:r>
-              <a:t>5/10</a:t>
+              <a:t>5/11</a:t>
             </a:r>
           </a:p>
         </p:txBody>
@@ -6299,7 +6768,7 @@
               </a:defRPr>
             </a:pPr>
             <a:r>
-              <a:t>6/10</a:t>
+              <a:t>6/11</a:t>
             </a:r>
           </a:p>
         </p:txBody>
@@ -6990,7 +7459,7 @@
               </a:defRPr>
             </a:pPr>
             <a:r>
-              <a:t>7/10</a:t>
+              <a:t>7/11</a:t>
             </a:r>
           </a:p>
         </p:txBody>
@@ -7448,7 +7917,7 @@
               </a:defRPr>
             </a:pPr>
             <a:r>
-              <a:t>8/10</a:t>
+              <a:t>8/11</a:t>
             </a:r>
           </a:p>
         </p:txBody>
@@ -7940,7 +8409,7 @@
               </a:defRPr>
             </a:pPr>
             <a:r>
-              <a:t>9/10</a:t>
+              <a:t>9/11</a:t>
             </a:r>
           </a:p>
         </p:txBody>

</xml_diff>

<commit_message>
docs(presentation): align PPTX slide 10 terminal boxes with web deck
</commit_message>
<xml_diff>
--- a/BookFlow_DevOps_Capstone_Presentation.pptx
+++ b/BookFlow_DevOps_Capstone_Presentation.pptx
@@ -3658,7 +3658,7 @@
         <p:spPr>
           <a:xfrm>
             <a:off x="731520" y="1463040"/>
-            <a:ext cx="5120640" cy="4754880"/>
+            <a:ext cx="5120640" cy="4846320"/>
           </a:xfrm>
           <a:prstGeom prst="roundRect">
             <a:avLst/>
@@ -3738,7 +3738,7 @@
         <p:spPr>
           <a:xfrm>
             <a:off x="914400" y="2103120"/>
-            <a:ext cx="4754880" cy="3931920"/>
+            <a:ext cx="4754880" cy="2286000"/>
           </a:xfrm>
           <a:prstGeom prst="rect">
             <a:avLst/>
@@ -3752,7 +3752,7 @@
           <a:lstStyle/>
           <a:p>
             <a:pPr>
-              <a:defRPr sz="1200">
+              <a:defRPr sz="1100">
                 <a:solidFill>
                   <a:srgbClr val="0F172A"/>
                 </a:solidFill>
@@ -3764,7 +3764,7 @@
           </a:p>
           <a:p>
             <a:pPr>
-              <a:defRPr sz="1200">
+              <a:defRPr sz="1100">
                 <a:solidFill>
                   <a:srgbClr val="0F172A"/>
                 </a:solidFill>
@@ -3776,7 +3776,7 @@
           </a:p>
           <a:p>
             <a:pPr>
-              <a:defRPr sz="1200">
+              <a:defRPr sz="1100">
                 <a:solidFill>
                   <a:srgbClr val="0F172A"/>
                 </a:solidFill>
@@ -3784,18 +3784,6 @@
             </a:pPr>
             <a:r>
               <a:t>▸ Automated Terraform Provisioning: 18 cloud resources provisioned via declarative HCL modules in terraform/ directory.</a:t>
-            </a:r>
-          </a:p>
-          <a:p>
-            <a:pPr>
-              <a:defRPr sz="1200">
-                <a:solidFill>
-                  <a:srgbClr val="0F172A"/>
-                </a:solidFill>
-              </a:defRPr>
-            </a:pPr>
-            <a:r>
-              <a:t>▸ Production Ingress &amp; Security Groups: Tight network security rules isolating worker nodes while exposing Ingress.</a:t>
             </a:r>
           </a:p>
         </p:txBody>
@@ -3808,8 +3796,71 @@
         </p:nvSpPr>
         <p:spPr>
           <a:xfrm>
+            <a:off x="914400" y="4663440"/>
+            <a:ext cx="4754880" cy="1371600"/>
+          </a:xfrm>
+          <a:prstGeom prst="roundRect">
+            <a:avLst/>
+          </a:prstGeom>
+          <a:solidFill>
+            <a:srgbClr val="0F172A"/>
+          </a:solidFill>
+          <a:ln>
+            <a:solidFill>
+              <a:srgbClr val="334155"/>
+            </a:solidFill>
+          </a:ln>
+        </p:spPr>
+        <p:style>
+          <a:lnRef idx="1">
+            <a:schemeClr val="accent1"/>
+          </a:lnRef>
+          <a:fillRef idx="3">
+            <a:schemeClr val="accent1"/>
+          </a:fillRef>
+          <a:effectRef idx="2">
+            <a:schemeClr val="accent1"/>
+          </a:effectRef>
+          <a:fontRef idx="minor">
+            <a:schemeClr val="lt1"/>
+          </a:fontRef>
+        </p:style>
+        <p:txBody>
+          <a:bodyPr rtlCol="0" anchor="ctr" wrap="square"/>
+          <a:lstStyle/>
+          <a:p>
+            <a:pPr algn="ctr">
+              <a:defRPr sz="1000">
+                <a:solidFill>
+                  <a:srgbClr val="10B981"/>
+                </a:solidFill>
+                <a:latin typeface="Consolas"/>
+              </a:defRPr>
+            </a:pPr>
+            <a:r>
+              <a:t>$ terraform apply -auto-approve</a:t>
+            </a:r>
+            <a:br/>
+            <a:r>
+              <a:t>✔ Apply complete! Resources: 18 added, 0 changed, 0 destroyed.</a:t>
+            </a:r>
+            <a:br/>
+            <a:r>
+              <a:t>Outputs: configure_kubectl = "aws eks update-kubeconfig..."</a:t>
+            </a:r>
+          </a:p>
+        </p:txBody>
+      </p:sp>
+      <p:sp>
+        <p:nvSpPr>
+          <p:cNvPr id="10" name="Rounded Rectangle 9"/>
+          <p:cNvSpPr/>
+          <p:nvPr/>
+        </p:nvSpPr>
+        <p:spPr>
+          <a:xfrm>
             <a:off x="6217920" y="1463040"/>
-            <a:ext cx="5212080" cy="4754880"/>
+            <a:ext cx="5212080" cy="4846320"/>
           </a:xfrm>
           <a:prstGeom prst="roundRect">
             <a:avLst/>
@@ -3847,7 +3898,7 @@
       </p:sp>
       <p:sp>
         <p:nvSpPr>
-          <p:cNvPr id="10" name="TextBox 9"/>
+          <p:cNvPr id="11" name="TextBox 10"/>
           <p:cNvSpPr txBox="1"/>
           <p:nvPr/>
         </p:nvSpPr>
@@ -3882,14 +3933,14 @@
       </p:sp>
       <p:sp>
         <p:nvSpPr>
-          <p:cNvPr id="11" name="TextBox 10"/>
+          <p:cNvPr id="12" name="TextBox 11"/>
           <p:cNvSpPr txBox="1"/>
           <p:nvPr/>
         </p:nvSpPr>
         <p:spPr>
           <a:xfrm>
             <a:off x="6400800" y="2103120"/>
-            <a:ext cx="4846320" cy="3931920"/>
+            <a:ext cx="4846320" cy="2286000"/>
           </a:xfrm>
           <a:prstGeom prst="rect">
             <a:avLst/>
@@ -3903,7 +3954,7 @@
           <a:lstStyle/>
           <a:p>
             <a:pPr>
-              <a:defRPr sz="1200">
+              <a:defRPr sz="1100">
                 <a:solidFill>
                   <a:srgbClr val="0F172A"/>
                 </a:solidFill>
@@ -3915,7 +3966,7 @@
           </a:p>
           <a:p>
             <a:pPr>
-              <a:defRPr sz="1200">
+              <a:defRPr sz="1100">
                 <a:solidFill>
                   <a:srgbClr val="0F172A"/>
                 </a:solidFill>
@@ -3927,7 +3978,7 @@
           </a:p>
           <a:p>
             <a:pPr>
-              <a:defRPr sz="1200">
+              <a:defRPr sz="1100">
                 <a:solidFill>
                   <a:srgbClr val="0F172A"/>
                 </a:solidFill>
@@ -3937,16 +3988,67 @@
               <a:t>▸ AWS EBS CSI Persistent Storage: AWS EBS CSI driver add-on attached to gp3 StorageClasses for PostgreSQL database durability.</a:t>
             </a:r>
           </a:p>
-          <a:p>
-            <a:pPr>
-              <a:defRPr sz="1200">
-                <a:solidFill>
-                  <a:srgbClr val="0F172A"/>
-                </a:solidFill>
-              </a:defRPr>
-            </a:pPr>
-            <a:r>
-              <a:t>▸ Multi-Tier BookFlow Workloads: Frontend (2 replicas) and backend (2 replicas) running healthy on AWS cloud nodes.</a:t>
+        </p:txBody>
+      </p:sp>
+      <p:sp>
+        <p:nvSpPr>
+          <p:cNvPr id="13" name="Rounded Rectangle 12"/>
+          <p:cNvSpPr/>
+          <p:nvPr/>
+        </p:nvSpPr>
+        <p:spPr>
+          <a:xfrm>
+            <a:off x="6400800" y="4663440"/>
+            <a:ext cx="4846320" cy="1371600"/>
+          </a:xfrm>
+          <a:prstGeom prst="roundRect">
+            <a:avLst/>
+          </a:prstGeom>
+          <a:solidFill>
+            <a:srgbClr val="0F172A"/>
+          </a:solidFill>
+          <a:ln>
+            <a:solidFill>
+              <a:srgbClr val="334155"/>
+            </a:solidFill>
+          </a:ln>
+        </p:spPr>
+        <p:style>
+          <a:lnRef idx="1">
+            <a:schemeClr val="accent1"/>
+          </a:lnRef>
+          <a:fillRef idx="3">
+            <a:schemeClr val="accent1"/>
+          </a:fillRef>
+          <a:effectRef idx="2">
+            <a:schemeClr val="accent1"/>
+          </a:effectRef>
+          <a:fontRef idx="minor">
+            <a:schemeClr val="lt1"/>
+          </a:fontRef>
+        </p:style>
+        <p:txBody>
+          <a:bodyPr rtlCol="0" anchor="ctr" wrap="square"/>
+          <a:lstStyle/>
+          <a:p>
+            <a:pPr algn="ctr">
+              <a:defRPr sz="1000">
+                <a:solidFill>
+                  <a:srgbClr val="10B981"/>
+                </a:solidFill>
+                <a:latin typeface="Consolas"/>
+              </a:defRPr>
+            </a:pPr>
+            <a:r>
+              <a:t>$ kubectl get nodes -o wide</a:t>
+            </a:r>
+            <a:br/>
+            <a:r>
+              <a:t>ip-10-20-1-42.ap-south-1.compute  Ready  node  v1.31.0-eks</a:t>
+            </a:r>
+            <a:br/>
+            <a:r>
+              <a:t>ip-10-20-2-88.ap-south-1.compute  Ready  node  v1.31.0-eks</a:t>
             </a:r>
           </a:p>
         </p:txBody>

</xml_diff>